<commit_message>
Sync Agenda2 and slides with Agenda updates
Add the manual automation note and the Caveman mention.

Co-Authored-By: Claude Opus 5.5 <noreply@anthropic.com>
</commit_message>
<xml_diff>
--- a/Propertybased_testing_webui_with_bombadil_and_playwright.pptx
+++ b/Propertybased_testing_webui_with_bombadil_and_playwright.pptx
@@ -4400,6 +4400,26 @@
             </a:r>
             <a:endParaRPr lang="en-US" sz="2400" dirty="0"/>
           </a:p>
+          <a:p>
+            <a:pPr marL="0" indent="0">
+              <a:spcBef>
+                <a:spcPts val="1000"/>
+              </a:spcBef>
+              <a:buNone/>
+            </a:pPr>
+            <a:r>
+              <a:rPr lang="en-US" sz="2400" b="0" dirty="0">
+                <a:solidFill>
+                  <a:srgbClr val="FFFFFF"/>
+                </a:solidFill>
+                <a:latin typeface="Arial" pitchFamily="34" charset="0"/>
+                <a:ea typeface="Arial" pitchFamily="34" charset="-122"/>
+                <a:cs typeface="Arial" pitchFamily="34" charset="-120"/>
+              </a:rPr>
+              <a:t>Maybe go Caveman?</a:t>
+            </a:r>
+            <a:endParaRPr lang="en-US" sz="2400" dirty="0"/>
+          </a:p>
         </p:txBody>
       </p:sp>
       <p:sp>
@@ -6370,6 +6390,48 @@
               <a:t>These are deterministic generated tests. Fewer tokens harmed by knowing the difference.</a:t>
             </a:r>
             <a:endParaRPr lang="en-US" sz="1800" dirty="0"/>
+          </a:p>
+          <a:p>
+            <a:pPr marL="0" indent="0">
+              <a:spcBef>
+                <a:spcPts val="1000"/>
+              </a:spcBef>
+              <a:buNone/>
+            </a:pPr>
+            <a:endParaRPr lang="en-US" sz="1800" dirty="0"/>
+            <a:r>
+              <a:rPr lang="en-US" sz="1800" dirty="0" b="0">
+                <a:solidFill>
+                  <a:srgbClr val="FFFFFF"/>
+                </a:solidFill>
+                <a:latin typeface="Arial" pitchFamily="34" charset="0"/>
+                <a:ea typeface="Arial" pitchFamily="34" charset="-122"/>
+                <a:cs typeface="Arial" pitchFamily="34" charset="-120"/>
+              </a:rPr>
+              <a:t>This </a:t>
+            </a:r>
+            <a:r>
+              <a:rPr lang="en-US" sz="1800" dirty="0" b="0" i="1">
+                <a:solidFill>
+                  <a:srgbClr val="FFFFFF"/>
+                </a:solidFill>
+                <a:latin typeface="Arial" pitchFamily="34" charset="0"/>
+                <a:ea typeface="Arial" pitchFamily="34" charset="-122"/>
+                <a:cs typeface="Arial" pitchFamily="34" charset="-120"/>
+              </a:rPr>
+              <a:t>manual automation</a:t>
+            </a:r>
+            <a:r>
+              <a:rPr lang="en-US" sz="1800" dirty="0" b="0">
+                <a:solidFill>
+                  <a:srgbClr val="FFFFFF"/>
+                </a:solidFill>
+                <a:latin typeface="Arial" pitchFamily="34" charset="0"/>
+                <a:ea typeface="Arial" pitchFamily="34" charset="-122"/>
+                <a:cs typeface="Arial" pitchFamily="34" charset="-120"/>
+              </a:rPr>
+              <a:t> demo belongs in a frame of true automation with pipelines.</a:t>
+            </a:r>
           </a:p>
         </p:txBody>
       </p:sp>

</xml_diff>

<commit_message>
Add antithesis research skill prompt
</commit_message>
<xml_diff>
--- a/Propertybased_testing_webui_with_bombadil_and_playwright.pptx
+++ b/Propertybased_testing_webui_with_bombadil_and_playwright.pptx
@@ -9136,6 +9136,26 @@
         <p:txBody>
           <a:bodyPr wrap="square" lIns="0" tIns="0" rIns="0" bIns="0" rtlCol="0" anchor="t"/>
           <a:lstStyle/>
+          <a:p>
+            <a:pPr marL="0" indent="0">
+              <a:spcAft>
+                <a:spcPts val="1000"/>
+              </a:spcAft>
+              <a:buNone/>
+            </a:pPr>
+            <a:r>
+              <a:rPr lang="en-US" sz="1400" dirty="0">
+                <a:solidFill>
+                  <a:srgbClr val="151515"/>
+                </a:solidFill>
+                <a:latin typeface="Courier New" pitchFamily="34" charset="0"/>
+                <a:ea typeface="Courier New" pitchFamily="34" charset="-122"/>
+                <a:cs typeface="Courier New" pitchFamily="34" charset="-120"/>
+              </a:rPr>
+              <a:t>Bring in antithesis research skill, and use that to identify properties. Or in this case, use what I already created on this on Monday.</a:t>
+            </a:r>
+            <a:endParaRPr lang="en-US" sz="1400" dirty="0"/>
+          </a:p>
           <a:p>
             <a:pPr marL="0" indent="0">
               <a:buNone/>

</xml_diff>